<commit_message>
docs: update scoring collection to grade mapping, 10-bucket matrix, and system docs
</commit_message>
<xml_diff>
--- a/CRMS_Presentation.pptx
+++ b/CRMS_Presentation.pptx
@@ -5973,7 +5973,7 @@
               </a:defRPr>
             </a:pPr>
             <a:r>
-              <a:t>LOW RISK (Score &gt; 750)</a:t>
+              <a:t>LOW RISK (Score &gt;= 700)</a:t>
             </a:r>
           </a:p>
         </p:txBody>
@@ -6008,7 +6008,7 @@
               </a:defRPr>
             </a:pPr>
             <a:r>
-              <a:t>Action Path 1 - 2</a:t>
+              <a:t>Action Path Grade 3 - 4</a:t>
             </a:r>
           </a:p>
           <a:p>
@@ -6020,7 +6020,7 @@
               </a:defRPr>
             </a:pPr>
             <a:r>
-              <a:t>Otomasi digital penuh (WhatsApp Bot Blaster, Smart IVR Robo-Call). Tidak perlu kunjungan fisik.</a:t>
+              <a:t>Challenger Digital-First: WhatsApp Bot Blaster &amp; Smart IVR Robo-Call. Hemat 100% kunjungan fisik DPD 1-30.</a:t>
             </a:r>
           </a:p>
         </p:txBody>
@@ -6117,7 +6117,7 @@
               </a:defRPr>
             </a:pPr>
             <a:r>
-              <a:t>MEDIUM RISK (Score 500-750)</a:t>
+              <a:t>MEDIUM RISK (Score 450-699)</a:t>
             </a:r>
           </a:p>
         </p:txBody>
@@ -6152,7 +6152,7 @@
               </a:defRPr>
             </a:pPr>
             <a:r>
-              <a:t>Action Path 3 - 4</a:t>
+              <a:t>Action Path Grade 5 - 6</a:t>
             </a:r>
           </a:p>
           <a:p>
@@ -6164,7 +6164,7 @@
               </a:defRPr>
             </a:pPr>
             <a:r>
-              <a:t>Sentralisasi Desk Telephony Head Office, penelusuran janji bayar, negosiasi restrukturisasi.</a:t>
+              <a:t>Challenger Hybrid: Desk Phone Telephony kantor &amp; eskalasi kunjungan lapangan Field Officer DPD 4/8+.</a:t>
             </a:r>
           </a:p>
         </p:txBody>
@@ -6261,7 +6261,7 @@
               </a:defRPr>
             </a:pPr>
             <a:r>
-              <a:t>HIGH RISK (Score &lt; 500)</a:t>
+              <a:t>HIGH RISK (Score &lt; 450)</a:t>
             </a:r>
           </a:p>
         </p:txBody>
@@ -6296,7 +6296,7 @@
               </a:defRPr>
             </a:pPr>
             <a:r>
-              <a:t>Action Path 5 - 8</a:t>
+              <a:t>Action Path Grade 7 - 8</a:t>
             </a:r>
           </a:p>
           <a:p>
@@ -6308,7 +6308,7 @@
               </a:defRPr>
             </a:pPr>
             <a:r>
-              <a:t>Eskalasi hybrid: Desk + Kunjungan langsung Field Officer mCollect &amp; penanganan Senior Remedial.</a:t>
+              <a:t>Challenger Intensive Field: Kunjungan Field Officer mCollect sejak DPD 1-18 &amp; Senior Field DPD 8/19+.</a:t>
             </a:r>
           </a:p>
         </p:txBody>
@@ -6440,7 +6440,7 @@
               </a:defRPr>
             </a:pPr>
             <a:r>
-              <a:t>Action Path VIP</a:t>
+              <a:t>Action Path Grade VIP</a:t>
             </a:r>
           </a:p>
           <a:p>
@@ -6452,7 +6452,7 @@
               </a:defRPr>
             </a:pPr>
             <a:r>
-              <a:t>Ditangani eksklusif di bawah kendali AR Head / Executive Desk untuk menjaga reputasi nasabah.</a:t>
+              <a:t>Ditangani eksklusif personal oleh AR Head / Tim Khusus di semua bucket untuk menjaga reputasi nasabah.</a:t>
             </a:r>
           </a:p>
         </p:txBody>
@@ -6585,7 +6585,7 @@
               </a:defRPr>
             </a:pPr>
             <a:r>
-              <a:t>• Pemisahan Alokasi Portofolio: 80% akun dialokasikan ke strategi Champion teruji, 20% dialokasikan ke Challenger untuk pengujian hipotesis baru.</a:t>
+              <a:t>• Pemisahan Alokasi Portofolio: 80% akun dialokasikan ke Champion (Grade 1 &amp; 2 baseline), 20% dialokasikan ke Challenger (Grade 3-8 adaptif risiko) untuk A/B testing.</a:t>
             </a:r>
           </a:p>
           <a:p>
@@ -6597,7 +6597,7 @@
               </a:defRPr>
             </a:pPr>
             <a:r>
-              <a:t>• A/B Testing Kinerja Penagihan: Membandingkan Cure Rate dan Roll Rate antara strategi Champion dan Challenger secara real-time.</a:t>
+              <a:t>• Jembatan Scoring ke Grade: Skor 0-1000 diklasifikasikan ke Risk Level -&gt; Dipetakan ke Grade 1-8 -&gt; Diinterseksikan dengan 10 Bucket DPD (-3-0 s/d &gt;150) untuk menentukan PIC.</a:t>
             </a:r>
           </a:p>
           <a:p>
@@ -6609,7 +6609,7 @@
               </a:defRPr>
             </a:pPr>
             <a:r>
-              <a:t>• Promosi Otomatis: Jika strategi Challenger menghasilkan Cure Rate lebih tinggi, algoritma dapat dipromosikan menjadi Champion baru.</a:t>
+              <a:t>• A/B Testing Sub-Varian: Membandingkan varian ganjil vs genap (kecepatan eskalasi waktu kontak) terhadap Cure Rate &amp; Roll Rate secara real-time.</a:t>
             </a:r>
           </a:p>
           <a:p>
@@ -6621,7 +6621,7 @@
               </a:defRPr>
             </a:pPr>
             <a:r>
-              <a:t>• Simulasi Evaluasi Ulang: Endpoint API `/overdue-accounts/:id/reevaluate` memungkinkan simulasi dampak perubahan aturan scoring.</a:t>
+              <a:t>• Promosi Otomatis: Strategi Challenger berkinerja tertinggi otomatis dipromosikan menjadi Champion baru; re-evaluasi instan via API reevaluate.</a:t>
             </a:r>
           </a:p>
         </p:txBody>
@@ -6754,7 +6754,7 @@
               </a:defRPr>
             </a:pPr>
             <a:r>
-              <a:t>• Riwayat Pembayaran Masa Lalu (35%): Rekam jejak ketepatan waktu angsuran 12 bulan terakhir dan frekuensi broken PTP.</a:t>
+              <a:t>• Riwayat Pembayaran Masa Lalu (35%): Rekam jejak ketepatan waktu angsuran 12 bulan terakhir dan rasio pemenuhan janji bayar (Kept PTP).</a:t>
             </a:r>
           </a:p>
           <a:p>
@@ -6766,7 +6766,7 @@
               </a:defRPr>
             </a:pPr>
             <a:r>
-              <a:t>• Days Past Due / DPD Berjalan (25%): Tingkat keterlambatan saat ini (Bucket 1-3, 4-7, ... &gt;150).</a:t>
+              <a:t>• Days Past Due / DPD Berjalan (25%): Posisi bucket keterlambatan dan akselerasi tunggakan (-3-0 s.d &gt;150).</a:t>
             </a:r>
           </a:p>
           <a:p>

</xml_diff>